<commit_message>
Session 6 worksheet: no sensitivity-analysis task (Level 2)
Co-Authored-By: Claude Opus 5.5 <noreply@anthropic.com>
</commit_message>
<xml_diff>
--- a/en/files/slides/Session_6_EN.pptx
+++ b/en/files/slides/Session_6_EN.pptx
@@ -4866,7 +4866,7 @@
           <a:p>
             <a:r>
               <a:rPr lang="en-US" sz="1400" b="0" dirty="0"/>
-              <a:t>Missing-data plan: expected missingness and why (MCAR / MAR / MNAR thinking), prevention (Session 5), the main handling and one sensitivity analysis, as FLUID-ICU did.</a:t>
+              <a:t>Missing-data plan: expected missingness and why (MCAR / MAR / MNAR thinking), prevention (Session 5), and how missing data will be reported (how many, in whom). Imputation and sensitivity analyses are Level 2 topics.</a:t>
             </a:r>
           </a:p>
         </p:txBody>
@@ -7179,7 +7179,7 @@
           <a:p>
             <a:r>
               <a:rPr lang="en-US" sz="1400" b="0" dirty="0"/>
-              <a:t>Plan: all of this goes in the SAP and in Part 3 of your proposal today: expected missingness, prevention (5.1), main handling, one sensitivity analysis.</a:t>
+              <a:t>Plan: all of this goes in the SAP and in Part 3 of your proposal today: expected missingness, prevention (5.1), and how missing data will be reported.</a:t>
             </a:r>
           </a:p>
           <a:p>
@@ -24639,7 +24639,7 @@
                 <a:latin typeface="Century Gothic"/>
                 <a:cs typeface="Century Gothic"/>
               </a:rPr>
-              <a:t>Did the missing-data sensitivity analysis change the answer?</a:t>
+              <a:t>Look at the imputation result in your pack: close to the main one? (details in Level 2)</a:t>
             </a:r>
           </a:p>
           <a:p>
@@ -26073,7 +26073,7 @@
                 <a:latin typeface="Century Gothic"/>
                 <a:cs typeface="Century Gothic"/>
               </a:rPr>
-              <a:t>Missing-data plan: expected gaps, prevention, main handling, one sensitivity analysis (7 min)</a:t>
+              <a:t>Missing-data plan: expected gaps, prevention, how missing data will be reported (7 min)</a:t>
             </a:r>
           </a:p>
         </p:txBody>
@@ -35332,7 +35332,7 @@
                 <a:latin typeface="Century Gothic"/>
                 <a:cs typeface="Century Gothic"/>
               </a:rPr>
-              <a:t>Sensitivity</a:t>
+              <a:t>Sensitivity (Level 2)</a:t>
             </a:r>
           </a:p>
         </p:txBody>
@@ -35402,7 +35402,7 @@
                 <a:latin typeface="Century Gothic"/>
                 <a:cs typeface="Century Gothic"/>
               </a:rPr>
-              <a:t>Best / worst case</a:t>
+              <a:t>Example script: 05_missing.R</a:t>
             </a:r>
           </a:p>
           <a:p>
@@ -35423,7 +35423,7 @@
                 <a:latin typeface="Century Gothic"/>
                 <a:cs typeface="Century Gothic"/>
               </a:rPr>
-              <a:t>Same answer?</a:t>
+              <a:t>Done hands-on in Level 2</a:t>
             </a:r>
           </a:p>
         </p:txBody>

</xml_diff>

<commit_message>
Rebuild site: round 6 (giảng viên, new deadlines, IMRaD taught as core)
</commit_message>
<xml_diff>
--- a/en/files/slides/Session_6_EN.pptx
+++ b/en/files/slides/Session_6_EN.pptx
@@ -4674,7 +4674,7 @@
           <a:p>
             <a:r>
               <a:rPr lang="en-US" sz="1400" b="0" dirty="0"/>
-              <a:t>Next Saturday: ethics, integrity and the Results section, written live on Q1.</a:t>
+              <a:t>Next Saturday: ethics, integrity, Methods and Results (the Results written live on Q1).</a:t>
             </a:r>
           </a:p>
         </p:txBody>
@@ -4755,7 +4755,7 @@
           <a:p>
             <a:r>
               <a:rPr lang="en-US" sz="1400" b="0" dirty="0"/>
-              <a:t>Product 2 (2 minutes). Say it plainly: we give you the results, you write a submission-ready Results section. The other sections are optional, and we give feedback on them too.</a:t>
+              <a:t>Product 2 (2 minutes). Say it plainly: we give you the results, you write a submission-ready Results section. The other sections are all taught in Sessions 7 and 8. Submitting them is optional, and we give feedback on them too.</a:t>
             </a:r>
           </a:p>
           <a:p>
@@ -30098,7 +30098,7 @@
                 <a:latin typeface="Arial"/>
                 <a:cs typeface="Arial"/>
               </a:rPr>
-              <a:t>Optional</a:t>
+              <a:t>Optional to submit</a:t>
             </a:r>
           </a:p>
         </p:txBody>
@@ -30189,7 +30189,7 @@
                 <a:latin typeface="Arial"/>
                 <a:cs typeface="Arial"/>
               </a:rPr>
-              <a:t>Trainers give feedback on these too</a:t>
+              <a:t>All taught in Sessions 7 and 8</a:t>
             </a:r>
           </a:p>
         </p:txBody>
@@ -30323,7 +30323,7 @@
                 <a:latin typeface="Arial"/>
                 <a:cs typeface="Arial"/>
               </a:rPr>
-              <a:t>Due 23:59 on the day of Session 8</a:t>
+              <a:t>Due 23:59, Sunday 20 December</a:t>
             </a:r>
           </a:p>
         </p:txBody>
@@ -30849,7 +30849,7 @@
                 <a:latin typeface="Arial"/>
                 <a:cs typeface="Arial"/>
               </a:rPr>
-              <a:t>Writing the Results section</a:t>
+              <a:t>Writing every section of a paper</a:t>
             </a:r>
           </a:p>
           <a:p>

</xml_diff>